<commit_message>
Corrigir gaps da auditoria: modelo de negócio no MD, lab FIAP, data capa
Co-Authored-By: Claude Opus 4.6 <noreply@anthropic.com>
</commit_message>
<xml_diff>
--- a/apresentacao_ev_chargeops_v4.pptx
+++ b/apresentacao_ev_chargeops_v4.pptx
@@ -4019,7 +4019,7 @@
                   <a:srgbClr val="FFFFFF"/>
                 </a:solidFill>
               </a:rPr>
-              <a:t>168</a:t>
+              <a:t>160</a:t>
             </a:r>
           </a:p>
           <a:p>
@@ -4082,7 +4082,7 @@
                   <a:srgbClr val="FFFFFF"/>
                 </a:solidFill>
               </a:rPr>
-              <a:t>5226 kWh</a:t>
+              <a:t>5260 kWh</a:t>
             </a:r>
           </a:p>
           <a:p>
@@ -4145,7 +4145,7 @@
                   <a:srgbClr val="FFFFFF"/>
                 </a:solidFill>
               </a:rPr>
-              <a:t>R$ 4762</a:t>
+              <a:t>R$ 4658</a:t>
             </a:r>
           </a:p>
           <a:p>
@@ -4208,7 +4208,7 @@
                   <a:srgbClr val="FFFFFF"/>
                 </a:solidFill>
               </a:rPr>
-              <a:t>31.1 kWh</a:t>
+              <a:t>32.9 kWh</a:t>
             </a:r>
           </a:p>
           <a:p>

</xml_diff>